<commit_message>
Deck layout: wrapped-line sizing, vertical centring, shorter prefill labels
</commit_message>
<xml_diff>
--- a/data/deck/ESR_replication.pptx
+++ b/data/deck/ESR_replication.pptx
@@ -4139,7 +4139,7 @@
         <p:spPr>
           <a:xfrm>
             <a:off x="640080" y="1143000"/>
-            <a:ext cx="10911535" cy="1024128"/>
+            <a:ext cx="10911535" cy="877824"/>
           </a:xfrm>
           <a:prstGeom prst="rect">
             <a:avLst/>
@@ -4226,8 +4226,8 @@
         </p:blipFill>
         <p:spPr>
           <a:xfrm>
-            <a:off x="1562855" y="2368296"/>
-            <a:ext cx="9065984" cy="4032504"/>
+            <a:off x="1398393" y="2221992"/>
+            <a:ext cx="9394908" cy="4178808"/>
           </a:xfrm>
           <a:prstGeom prst="rect">
             <a:avLst/>
@@ -4339,7 +4339,7 @@
         <p:spPr>
           <a:xfrm>
             <a:off x="640080" y="1143000"/>
-            <a:ext cx="10911535" cy="1024128"/>
+            <a:ext cx="10911535" cy="877824"/>
           </a:xfrm>
           <a:prstGeom prst="rect">
             <a:avLst/>
@@ -4426,8 +4426,8 @@
         </p:blipFill>
         <p:spPr>
           <a:xfrm>
-            <a:off x="704875" y="2368296"/>
-            <a:ext cx="10781943" cy="4032504"/>
+            <a:off x="548639" y="2221992"/>
+            <a:ext cx="11094415" cy="4149370"/>
           </a:xfrm>
           <a:prstGeom prst="rect">
             <a:avLst/>
@@ -4539,7 +4539,7 @@
         <p:spPr>
           <a:xfrm>
             <a:off x="640080" y="1143000"/>
-            <a:ext cx="10911535" cy="1024128"/>
+            <a:ext cx="10911535" cy="877824"/>
           </a:xfrm>
           <a:prstGeom prst="rect">
             <a:avLst/>
@@ -4626,8 +4626,8 @@
         </p:blipFill>
         <p:spPr>
           <a:xfrm>
-            <a:off x="2260420" y="2368296"/>
-            <a:ext cx="7670853" cy="4032504"/>
+            <a:off x="2121267" y="2221992"/>
+            <a:ext cx="7949161" cy="4178808"/>
           </a:xfrm>
           <a:prstGeom prst="rect">
             <a:avLst/>
@@ -4738,8 +4738,8 @@
         </p:nvSpPr>
         <p:spPr>
           <a:xfrm>
-            <a:off x="640080" y="1143000"/>
-            <a:ext cx="10911535" cy="1645920"/>
+            <a:off x="640080" y="1609343"/>
+            <a:ext cx="10911535" cy="3090672"/>
           </a:xfrm>
           <a:prstGeom prst="rect">
             <a:avLst/>
@@ -4761,7 +4761,7 @@
               </a:spcAft>
             </a:pPr>
             <a:r>
-              <a:rPr sz="1500" b="0">
+              <a:rPr sz="1800" b="0">
                 <a:solidFill>
                   <a:srgbClr val="000000"/>
                 </a:solidFill>
@@ -4780,7 +4780,7 @@
               </a:spcAft>
             </a:pPr>
             <a:r>
-              <a:rPr sz="1500" b="0">
+              <a:rPr sz="1800" b="0">
                 <a:solidFill>
                   <a:srgbClr val="000000"/>
                 </a:solidFill>
@@ -4799,7 +4799,7 @@
               </a:spcAft>
             </a:pPr>
             <a:r>
-              <a:rPr sz="1500" b="0">
+              <a:rPr sz="1800" b="0">
                 <a:solidFill>
                   <a:srgbClr val="000000"/>
                 </a:solidFill>
@@ -4818,7 +4818,7 @@
               </a:spcAft>
             </a:pPr>
             <a:r>
-              <a:rPr sz="1500" b="0">
+              <a:rPr sz="1800" b="0">
                 <a:solidFill>
                   <a:srgbClr val="000000"/>
                 </a:solidFill>
@@ -4837,7 +4837,7 @@
               </a:spcAft>
             </a:pPr>
             <a:r>
-              <a:rPr sz="1500" b="0">
+              <a:rPr sz="1800" b="0">
                 <a:solidFill>
                   <a:srgbClr val="000000"/>
                 </a:solidFill>
@@ -4952,8 +4952,8 @@
         </p:nvSpPr>
         <p:spPr>
           <a:xfrm>
-            <a:off x="640080" y="1143000"/>
-            <a:ext cx="10911535" cy="1645920"/>
+            <a:off x="640080" y="1609343"/>
+            <a:ext cx="10911535" cy="3090672"/>
           </a:xfrm>
           <a:prstGeom prst="rect">
             <a:avLst/>
@@ -4975,7 +4975,7 @@
               </a:spcAft>
             </a:pPr>
             <a:r>
-              <a:rPr sz="1600" b="0">
+              <a:rPr sz="1800" b="0">
                 <a:solidFill>
                   <a:srgbClr val="000000"/>
                 </a:solidFill>
@@ -4994,7 +4994,7 @@
               </a:spcAft>
             </a:pPr>
             <a:r>
-              <a:rPr sz="1600" b="0">
+              <a:rPr sz="1800" b="0">
                 <a:solidFill>
                   <a:srgbClr val="000000"/>
                 </a:solidFill>
@@ -5013,7 +5013,7 @@
               </a:spcAft>
             </a:pPr>
             <a:r>
-              <a:rPr sz="1600" b="0">
+              <a:rPr sz="1800" b="0">
                 <a:solidFill>
                   <a:srgbClr val="000000"/>
                 </a:solidFill>
@@ -5032,7 +5032,7 @@
               </a:spcAft>
             </a:pPr>
             <a:r>
-              <a:rPr sz="1600" b="0">
+              <a:rPr sz="1800" b="0">
                 <a:solidFill>
                   <a:srgbClr val="000000"/>
                 </a:solidFill>
@@ -5051,7 +5051,7 @@
               </a:spcAft>
             </a:pPr>
             <a:r>
-              <a:rPr sz="1600" b="0">
+              <a:rPr sz="1800" b="0">
                 <a:solidFill>
                   <a:srgbClr val="000000"/>
                 </a:solidFill>
@@ -5287,7 +5287,7 @@
         <p:spPr>
           <a:xfrm>
             <a:off x="640080" y="1143000"/>
-            <a:ext cx="10911535" cy="713232"/>
+            <a:ext cx="10911535" cy="640080"/>
           </a:xfrm>
           <a:prstGeom prst="rect">
             <a:avLst/>
@@ -5444,7 +5444,7 @@
         <p:spPr>
           <a:xfrm>
             <a:off x="640080" y="1143000"/>
-            <a:ext cx="10911535" cy="713232"/>
+            <a:ext cx="10911535" cy="640080"/>
           </a:xfrm>
           <a:prstGeom prst="rect">
             <a:avLst/>
@@ -5512,7 +5512,7 @@
         </p:blipFill>
         <p:spPr>
           <a:xfrm>
-            <a:off x="548639" y="2057400"/>
+            <a:off x="548639" y="1984248"/>
             <a:ext cx="11094415" cy="4133213"/>
           </a:xfrm>
           <a:prstGeom prst="rect">
@@ -5745,7 +5745,7 @@
         <p:spPr>
           <a:xfrm>
             <a:off x="640080" y="1143000"/>
-            <a:ext cx="10911535" cy="1024128"/>
+            <a:ext cx="10911535" cy="877824"/>
           </a:xfrm>
           <a:prstGeom prst="rect">
             <a:avLst/>
@@ -5832,7 +5832,7 @@
         </p:blipFill>
         <p:spPr>
           <a:xfrm>
-            <a:off x="548639" y="2368296"/>
+            <a:off x="548639" y="2221992"/>
             <a:ext cx="11094415" cy="3696105"/>
           </a:xfrm>
           <a:prstGeom prst="rect">
@@ -5944,8 +5944,8 @@
         </p:nvSpPr>
         <p:spPr>
           <a:xfrm>
-            <a:off x="640080" y="1143000"/>
-            <a:ext cx="10911535" cy="1645920"/>
+            <a:off x="640080" y="2340864"/>
+            <a:ext cx="10911535" cy="1627632"/>
           </a:xfrm>
           <a:prstGeom prst="rect">
             <a:avLst/>
@@ -5967,7 +5967,7 @@
               </a:spcAft>
             </a:pPr>
             <a:r>
-              <a:rPr sz="1500" b="0">
+              <a:rPr sz="1800" b="0">
                 <a:solidFill>
                   <a:srgbClr val="000000"/>
                 </a:solidFill>
@@ -5986,7 +5986,7 @@
               </a:spcAft>
             </a:pPr>
             <a:r>
-              <a:rPr sz="1500" b="0">
+              <a:rPr sz="1800" b="0">
                 <a:solidFill>
                   <a:srgbClr val="000000"/>
                 </a:solidFill>
@@ -6005,7 +6005,7 @@
               </a:spcAft>
             </a:pPr>
             <a:r>
-              <a:rPr sz="1500" b="0">
+              <a:rPr sz="1800" b="0">
                 <a:solidFill>
                   <a:srgbClr val="000000"/>
                 </a:solidFill>
@@ -6024,7 +6024,7 @@
               </a:spcAft>
             </a:pPr>
             <a:r>
-              <a:rPr sz="1500" b="0">
+              <a:rPr sz="1800" b="0">
                 <a:solidFill>
                   <a:srgbClr val="000000"/>
                 </a:solidFill>
@@ -6043,7 +6043,7 @@
               </a:spcAft>
             </a:pPr>
             <a:r>
-              <a:rPr sz="1500" b="0">
+              <a:rPr sz="1800" b="0">
                 <a:solidFill>
                   <a:srgbClr val="000000"/>
                 </a:solidFill>
@@ -6159,7 +6159,7 @@
         <p:spPr>
           <a:xfrm>
             <a:off x="640080" y="1143000"/>
-            <a:ext cx="10911535" cy="713232"/>
+            <a:ext cx="10911535" cy="640080"/>
           </a:xfrm>
           <a:prstGeom prst="rect">
             <a:avLst/>
@@ -6227,8 +6227,8 @@
         </p:blipFill>
         <p:spPr>
           <a:xfrm>
-            <a:off x="601009" y="2057400"/>
-            <a:ext cx="10989676" cy="4343400"/>
+            <a:off x="548639" y="1984248"/>
+            <a:ext cx="11094415" cy="4384795"/>
           </a:xfrm>
           <a:prstGeom prst="rect">
             <a:avLst/>

</xml_diff>

<commit_message>
Boost sweep figure and final ESR deck (14 slides, all figures present)
</commit_message>
<xml_diff>
--- a/data/deck/ESR_replication.pptx
+++ b/data/deck/ESR_replication.pptx
@@ -655,7 +655,7 @@
           <a:lstStyle/>
           <a:p>
             <a:r>
-              <a:t>This is the practical reason the experiment needs per-latent calibration.</a:t>
+              <a:t>Gemma-2-2B, 4 latents x 6 strengths x 3 trials. This is the practical reason the experiment needs per-latent calibration rather than one shared setting.</a:t>
             </a:r>
           </a:p>
         </p:txBody>
@@ -5287,7 +5287,7 @@
         <p:spPr>
           <a:xfrm>
             <a:off x="640080" y="1143000"/>
-            <a:ext cx="10911535" cy="640080"/>
+            <a:ext cx="10911535" cy="877824"/>
           </a:xfrm>
           <a:prstGeom prst="rect">
             <a:avLst/>
@@ -5315,7 +5315,7 @@
                 </a:solidFill>
                 <a:latin typeface="Calibri"/>
               </a:rPr>
-              <a:t>•  Too weak: nothing changes. Too strong: the text collapses into repetition.</a:t>
+              <a:t>•  Relevance falls from 73 to 9 as strength rises, while repeated word pairs go from 3% to 40%.</a:t>
             </a:r>
           </a:p>
           <a:p>
@@ -5334,14 +5334,57 @@
                 </a:solidFill>
                 <a:latin typeface="Calibri"/>
               </a:rPr>
-              <a:t>•  Self-correction can only happen in between, which is why strength has to be calibrated.</a:t>
-            </a:r>
-          </a:p>
-        </p:txBody>
-      </p:sp>
-      <p:sp>
-        <p:nvSpPr>
-          <p:cNvPr id="4" name="TextBox 3"/>
+              <a:t>•  Self-correction can only happen in between: off topic but still coherent.</a:t>
+            </a:r>
+          </a:p>
+          <a:p>
+            <a:pPr>
+              <a:lnSpc>
+                <a:spcPct val="115000"/>
+              </a:lnSpc>
+              <a:spcAft>
+                <a:spcPts val="600"/>
+              </a:spcAft>
+            </a:pPr>
+            <a:r>
+              <a:rPr sz="1500" b="0">
+                <a:solidFill>
+                  <a:srgbClr val="000000"/>
+                </a:solidFill>
+                <a:latin typeface="Calibri"/>
+              </a:rPr>
+              <a:t>•  The target band is crossed near 0.7, which is where the per-latent calibration lands.</a:t>
+            </a:r>
+          </a:p>
+        </p:txBody>
+      </p:sp>
+      <p:pic>
+        <p:nvPicPr>
+          <p:cNvPr id="4" name="Picture 3" descr="fig02_boost_sweep.png"/>
+          <p:cNvPicPr>
+            <a:picLocks noChangeAspect="1"/>
+          </p:cNvPicPr>
+          <p:nvPr/>
+        </p:nvPicPr>
+        <p:blipFill>
+          <a:blip r:embed="rId2"/>
+          <a:stretch>
+            <a:fillRect/>
+          </a:stretch>
+        </p:blipFill>
+        <p:spPr>
+          <a:xfrm>
+            <a:off x="548639" y="2221992"/>
+            <a:ext cx="11094415" cy="4133213"/>
+          </a:xfrm>
+          <a:prstGeom prst="rect">
+            <a:avLst/>
+          </a:prstGeom>
+        </p:spPr>
+      </p:pic>
+      <p:sp>
+        <p:nvSpPr>
+          <p:cNvPr id="5" name="TextBox 4"/>
           <p:cNvSpPr txBox="1"/>
           <p:nvPr/>
         </p:nvSpPr>

</xml_diff>